<commit_message>
update text, bw photo
</commit_message>
<xml_diff>
--- a/src/data/images.pptx
+++ b/src/data/images.pptx
@@ -12,6 +12,7 @@
     <p:sldId id="260" r:id="rId6"/>
     <p:sldId id="261" r:id="rId7"/>
     <p:sldId id="262" r:id="rId8"/>
+    <p:sldId id="263" r:id="rId9"/>
   </p:sldIdLst>
   <p:sldSz cx="12192000" cy="6858000"/>
   <p:notesSz cx="6858000" cy="9144000"/>
@@ -265,7 +266,7 @@
           <a:p>
             <a:fld id="{621A180A-8C38-4DA9-BE14-020F85743E22}" type="datetimeFigureOut">
               <a:rPr lang="en-US" smtClean="0"/>
-              <a:t>1/29/2025</a:t>
+              <a:t>4/24/2025</a:t>
             </a:fld>
             <a:endParaRPr lang="en-US"/>
           </a:p>
@@ -463,7 +464,7 @@
           <a:p>
             <a:fld id="{621A180A-8C38-4DA9-BE14-020F85743E22}" type="datetimeFigureOut">
               <a:rPr lang="en-US" smtClean="0"/>
-              <a:t>1/29/2025</a:t>
+              <a:t>4/24/2025</a:t>
             </a:fld>
             <a:endParaRPr lang="en-US"/>
           </a:p>
@@ -671,7 +672,7 @@
           <a:p>
             <a:fld id="{621A180A-8C38-4DA9-BE14-020F85743E22}" type="datetimeFigureOut">
               <a:rPr lang="en-US" smtClean="0"/>
-              <a:t>1/29/2025</a:t>
+              <a:t>4/24/2025</a:t>
             </a:fld>
             <a:endParaRPr lang="en-US"/>
           </a:p>
@@ -869,7 +870,7 @@
           <a:p>
             <a:fld id="{621A180A-8C38-4DA9-BE14-020F85743E22}" type="datetimeFigureOut">
               <a:rPr lang="en-US" smtClean="0"/>
-              <a:t>1/29/2025</a:t>
+              <a:t>4/24/2025</a:t>
             </a:fld>
             <a:endParaRPr lang="en-US"/>
           </a:p>
@@ -1144,7 +1145,7 @@
           <a:p>
             <a:fld id="{621A180A-8C38-4DA9-BE14-020F85743E22}" type="datetimeFigureOut">
               <a:rPr lang="en-US" smtClean="0"/>
-              <a:t>1/29/2025</a:t>
+              <a:t>4/24/2025</a:t>
             </a:fld>
             <a:endParaRPr lang="en-US"/>
           </a:p>
@@ -1409,7 +1410,7 @@
           <a:p>
             <a:fld id="{621A180A-8C38-4DA9-BE14-020F85743E22}" type="datetimeFigureOut">
               <a:rPr lang="en-US" smtClean="0"/>
-              <a:t>1/29/2025</a:t>
+              <a:t>4/24/2025</a:t>
             </a:fld>
             <a:endParaRPr lang="en-US"/>
           </a:p>
@@ -1821,7 +1822,7 @@
           <a:p>
             <a:fld id="{621A180A-8C38-4DA9-BE14-020F85743E22}" type="datetimeFigureOut">
               <a:rPr lang="en-US" smtClean="0"/>
-              <a:t>1/29/2025</a:t>
+              <a:t>4/24/2025</a:t>
             </a:fld>
             <a:endParaRPr lang="en-US"/>
           </a:p>
@@ -1962,7 +1963,7 @@
           <a:p>
             <a:fld id="{621A180A-8C38-4DA9-BE14-020F85743E22}" type="datetimeFigureOut">
               <a:rPr lang="en-US" smtClean="0"/>
-              <a:t>1/29/2025</a:t>
+              <a:t>4/24/2025</a:t>
             </a:fld>
             <a:endParaRPr lang="en-US"/>
           </a:p>
@@ -2075,7 +2076,7 @@
           <a:p>
             <a:fld id="{621A180A-8C38-4DA9-BE14-020F85743E22}" type="datetimeFigureOut">
               <a:rPr lang="en-US" smtClean="0"/>
-              <a:t>1/29/2025</a:t>
+              <a:t>4/24/2025</a:t>
             </a:fld>
             <a:endParaRPr lang="en-US"/>
           </a:p>
@@ -2386,7 +2387,7 @@
           <a:p>
             <a:fld id="{621A180A-8C38-4DA9-BE14-020F85743E22}" type="datetimeFigureOut">
               <a:rPr lang="en-US" smtClean="0"/>
-              <a:t>1/29/2025</a:t>
+              <a:t>4/24/2025</a:t>
             </a:fld>
             <a:endParaRPr lang="en-US"/>
           </a:p>
@@ -2674,7 +2675,7 @@
           <a:p>
             <a:fld id="{621A180A-8C38-4DA9-BE14-020F85743E22}" type="datetimeFigureOut">
               <a:rPr lang="en-US" smtClean="0"/>
-              <a:t>1/29/2025</a:t>
+              <a:t>4/24/2025</a:t>
             </a:fld>
             <a:endParaRPr lang="en-US"/>
           </a:p>
@@ -2915,7 +2916,7 @@
           <a:p>
             <a:fld id="{621A180A-8C38-4DA9-BE14-020F85743E22}" type="datetimeFigureOut">
               <a:rPr lang="en-US" smtClean="0"/>
-              <a:t>1/29/2025</a:t>
+              <a:t>4/24/2025</a:t>
             </a:fld>
             <a:endParaRPr lang="en-US"/>
           </a:p>
@@ -4078,6 +4079,103 @@
 </p:sld>
 </file>
 
+<file path=ppt/slides/slide8.xml><?xml version="1.0" encoding="utf-8"?>
+<p:sld xmlns:a="http://schemas.openxmlformats.org/drawingml/2006/main" xmlns:r="http://schemas.openxmlformats.org/officeDocument/2006/relationships" xmlns:p="http://schemas.openxmlformats.org/presentationml/2006/main">
+  <p:cSld>
+    <p:spTree>
+      <p:nvGrpSpPr>
+        <p:cNvPr id="1" name=""/>
+        <p:cNvGrpSpPr/>
+        <p:nvPr/>
+      </p:nvGrpSpPr>
+      <p:grpSpPr>
+        <a:xfrm>
+          <a:off x="0" y="0"/>
+          <a:ext cx="0" cy="0"/>
+          <a:chOff x="0" y="0"/>
+          <a:chExt cx="0" cy="0"/>
+        </a:xfrm>
+      </p:grpSpPr>
+      <p:sp>
+        <p:nvSpPr>
+          <p:cNvPr id="2" name="Title 1">
+            <a:extLst>
+              <a:ext uri="{FF2B5EF4-FFF2-40B4-BE49-F238E27FC236}">
+                <a16:creationId xmlns:a16="http://schemas.microsoft.com/office/drawing/2014/main" id="{6F25426D-49CE-4866-992B-BD5EE93A10DA}"/>
+              </a:ext>
+            </a:extLst>
+          </p:cNvPr>
+          <p:cNvSpPr>
+            <a:spLocks noGrp="1"/>
+          </p:cNvSpPr>
+          <p:nvPr>
+            <p:ph type="title"/>
+          </p:nvPr>
+        </p:nvSpPr>
+        <p:spPr/>
+        <p:txBody>
+          <a:bodyPr/>
+          <a:lstStyle/>
+          <a:p>
+            <a:endParaRPr lang="en-US"/>
+          </a:p>
+        </p:txBody>
+      </p:sp>
+      <p:pic>
+        <p:nvPicPr>
+          <p:cNvPr id="5" name="Content Placeholder 4">
+            <a:extLst>
+              <a:ext uri="{FF2B5EF4-FFF2-40B4-BE49-F238E27FC236}">
+                <a16:creationId xmlns:a16="http://schemas.microsoft.com/office/drawing/2014/main" id="{64F6F3F8-0D62-4BBB-AD3A-D6A324357DD9}"/>
+              </a:ext>
+            </a:extLst>
+          </p:cNvPr>
+          <p:cNvPicPr>
+            <a:picLocks noGrp="1" noChangeAspect="1"/>
+          </p:cNvPicPr>
+          <p:nvPr>
+            <p:ph idx="1"/>
+          </p:nvPr>
+        </p:nvPicPr>
+        <p:blipFill>
+          <a:blip r:embed="rId2">
+            <a:duotone>
+              <a:prstClr val="black"/>
+              <a:schemeClr val="accent3">
+                <a:tint val="45000"/>
+                <a:satMod val="400000"/>
+              </a:schemeClr>
+            </a:duotone>
+            <a:extLst>
+              <a:ext uri="{28A0092B-C50C-407E-A947-70E740481C1C}">
+                <a14:useLocalDpi xmlns:a14="http://schemas.microsoft.com/office/drawing/2010/main" val="0"/>
+              </a:ext>
+            </a:extLst>
+          </a:blip>
+          <a:stretch>
+            <a:fillRect/>
+          </a:stretch>
+        </p:blipFill>
+        <p:spPr>
+          <a:xfrm>
+            <a:off x="2564489" y="469783"/>
+            <a:ext cx="5436511" cy="5436511"/>
+          </a:xfrm>
+        </p:spPr>
+      </p:pic>
+    </p:spTree>
+    <p:extLst>
+      <p:ext uri="{BB962C8B-B14F-4D97-AF65-F5344CB8AC3E}">
+        <p14:creationId xmlns:p14="http://schemas.microsoft.com/office/powerpoint/2010/main" val="3005326315"/>
+      </p:ext>
+    </p:extLst>
+  </p:cSld>
+  <p:clrMapOvr>
+    <a:masterClrMapping/>
+  </p:clrMapOvr>
+</p:sld>
+</file>
+
 <file path=ppt/theme/theme1.xml><?xml version="1.0" encoding="utf-8"?>
 <a:theme xmlns:a="http://schemas.openxmlformats.org/drawingml/2006/main" name="Office Theme">
   <a:themeElements>

</xml_diff>

<commit_message>
add halloween, refactor and update readme
</commit_message>
<xml_diff>
--- a/src/data/images.pptx
+++ b/src/data/images.pptx
@@ -6,16 +6,17 @@
   </p:sldMasterIdLst>
   <p:sldIdLst>
     <p:sldId id="256" r:id="rId2"/>
-    <p:sldId id="258" r:id="rId3"/>
-    <p:sldId id="257" r:id="rId4"/>
-    <p:sldId id="259" r:id="rId5"/>
-    <p:sldId id="260" r:id="rId6"/>
-    <p:sldId id="261" r:id="rId7"/>
-    <p:sldId id="262" r:id="rId8"/>
-    <p:sldId id="263" r:id="rId9"/>
-    <p:sldId id="264" r:id="rId10"/>
-    <p:sldId id="266" r:id="rId11"/>
-    <p:sldId id="265" r:id="rId12"/>
+    <p:sldId id="267" r:id="rId3"/>
+    <p:sldId id="258" r:id="rId4"/>
+    <p:sldId id="257" r:id="rId5"/>
+    <p:sldId id="259" r:id="rId6"/>
+    <p:sldId id="260" r:id="rId7"/>
+    <p:sldId id="261" r:id="rId8"/>
+    <p:sldId id="262" r:id="rId9"/>
+    <p:sldId id="263" r:id="rId10"/>
+    <p:sldId id="264" r:id="rId11"/>
+    <p:sldId id="266" r:id="rId12"/>
+    <p:sldId id="265" r:id="rId13"/>
   </p:sldIdLst>
   <p:sldSz cx="12192000" cy="6858000"/>
   <p:notesSz cx="6858000" cy="9144000"/>
@@ -269,7 +270,7 @@
           <a:p>
             <a:fld id="{621A180A-8C38-4DA9-BE14-020F85743E22}" type="datetimeFigureOut">
               <a:rPr lang="en-US" smtClean="0"/>
-              <a:t>4/24/2025</a:t>
+              <a:t>12/28/2025</a:t>
             </a:fld>
             <a:endParaRPr lang="en-US"/>
           </a:p>
@@ -467,7 +468,7 @@
           <a:p>
             <a:fld id="{621A180A-8C38-4DA9-BE14-020F85743E22}" type="datetimeFigureOut">
               <a:rPr lang="en-US" smtClean="0"/>
-              <a:t>4/24/2025</a:t>
+              <a:t>12/28/2025</a:t>
             </a:fld>
             <a:endParaRPr lang="en-US"/>
           </a:p>
@@ -675,7 +676,7 @@
           <a:p>
             <a:fld id="{621A180A-8C38-4DA9-BE14-020F85743E22}" type="datetimeFigureOut">
               <a:rPr lang="en-US" smtClean="0"/>
-              <a:t>4/24/2025</a:t>
+              <a:t>12/28/2025</a:t>
             </a:fld>
             <a:endParaRPr lang="en-US"/>
           </a:p>
@@ -873,7 +874,7 @@
           <a:p>
             <a:fld id="{621A180A-8C38-4DA9-BE14-020F85743E22}" type="datetimeFigureOut">
               <a:rPr lang="en-US" smtClean="0"/>
-              <a:t>4/24/2025</a:t>
+              <a:t>12/28/2025</a:t>
             </a:fld>
             <a:endParaRPr lang="en-US"/>
           </a:p>
@@ -1148,7 +1149,7 @@
           <a:p>
             <a:fld id="{621A180A-8C38-4DA9-BE14-020F85743E22}" type="datetimeFigureOut">
               <a:rPr lang="en-US" smtClean="0"/>
-              <a:t>4/24/2025</a:t>
+              <a:t>12/28/2025</a:t>
             </a:fld>
             <a:endParaRPr lang="en-US"/>
           </a:p>
@@ -1413,7 +1414,7 @@
           <a:p>
             <a:fld id="{621A180A-8C38-4DA9-BE14-020F85743E22}" type="datetimeFigureOut">
               <a:rPr lang="en-US" smtClean="0"/>
-              <a:t>4/24/2025</a:t>
+              <a:t>12/28/2025</a:t>
             </a:fld>
             <a:endParaRPr lang="en-US"/>
           </a:p>
@@ -1825,7 +1826,7 @@
           <a:p>
             <a:fld id="{621A180A-8C38-4DA9-BE14-020F85743E22}" type="datetimeFigureOut">
               <a:rPr lang="en-US" smtClean="0"/>
-              <a:t>4/24/2025</a:t>
+              <a:t>12/28/2025</a:t>
             </a:fld>
             <a:endParaRPr lang="en-US"/>
           </a:p>
@@ -1966,7 +1967,7 @@
           <a:p>
             <a:fld id="{621A180A-8C38-4DA9-BE14-020F85743E22}" type="datetimeFigureOut">
               <a:rPr lang="en-US" smtClean="0"/>
-              <a:t>4/24/2025</a:t>
+              <a:t>12/28/2025</a:t>
             </a:fld>
             <a:endParaRPr lang="en-US"/>
           </a:p>
@@ -2079,7 +2080,7 @@
           <a:p>
             <a:fld id="{621A180A-8C38-4DA9-BE14-020F85743E22}" type="datetimeFigureOut">
               <a:rPr lang="en-US" smtClean="0"/>
-              <a:t>4/24/2025</a:t>
+              <a:t>12/28/2025</a:t>
             </a:fld>
             <a:endParaRPr lang="en-US"/>
           </a:p>
@@ -2390,7 +2391,7 @@
           <a:p>
             <a:fld id="{621A180A-8C38-4DA9-BE14-020F85743E22}" type="datetimeFigureOut">
               <a:rPr lang="en-US" smtClean="0"/>
-              <a:t>4/24/2025</a:t>
+              <a:t>12/28/2025</a:t>
             </a:fld>
             <a:endParaRPr lang="en-US"/>
           </a:p>
@@ -2678,7 +2679,7 @@
           <a:p>
             <a:fld id="{621A180A-8C38-4DA9-BE14-020F85743E22}" type="datetimeFigureOut">
               <a:rPr lang="en-US" smtClean="0"/>
-              <a:t>4/24/2025</a:t>
+              <a:t>12/28/2025</a:t>
             </a:fld>
             <a:endParaRPr lang="en-US"/>
           </a:p>
@@ -2919,7 +2920,7 @@
           <a:p>
             <a:fld id="{621A180A-8C38-4DA9-BE14-020F85743E22}" type="datetimeFigureOut">
               <a:rPr lang="en-US" smtClean="0"/>
-              <a:t>4/24/2025</a:t>
+              <a:t>12/28/2025</a:t>
             </a:fld>
             <a:endParaRPr lang="en-US"/>
           </a:p>
@@ -3450,6 +3451,115 @@
           <p:cNvPr id="2" name="Title 1">
             <a:extLst>
               <a:ext uri="{FF2B5EF4-FFF2-40B4-BE49-F238E27FC236}">
+                <a16:creationId xmlns:a16="http://schemas.microsoft.com/office/drawing/2014/main" id="{0BCB046E-2FC3-4408-8943-A295B7B1A566}"/>
+              </a:ext>
+            </a:extLst>
+          </p:cNvPr>
+          <p:cNvSpPr>
+            <a:spLocks noGrp="1"/>
+          </p:cNvSpPr>
+          <p:nvPr>
+            <p:ph type="title"/>
+          </p:nvPr>
+        </p:nvSpPr>
+        <p:spPr/>
+        <p:txBody>
+          <a:bodyPr/>
+          <a:lstStyle/>
+          <a:p>
+            <a:endParaRPr lang="en-US"/>
+          </a:p>
+        </p:txBody>
+      </p:sp>
+      <p:sp>
+        <p:nvSpPr>
+          <p:cNvPr id="3" name="Content Placeholder 2">
+            <a:extLst>
+              <a:ext uri="{FF2B5EF4-FFF2-40B4-BE49-F238E27FC236}">
+                <a16:creationId xmlns:a16="http://schemas.microsoft.com/office/drawing/2014/main" id="{52413933-3B51-4EDA-84AA-EFE19A6C69A1}"/>
+              </a:ext>
+            </a:extLst>
+          </p:cNvPr>
+          <p:cNvSpPr>
+            <a:spLocks noGrp="1"/>
+          </p:cNvSpPr>
+          <p:nvPr>
+            <p:ph idx="1"/>
+          </p:nvPr>
+        </p:nvSpPr>
+        <p:spPr/>
+        <p:txBody>
+          <a:bodyPr/>
+          <a:lstStyle/>
+          <a:p>
+            <a:endParaRPr lang="en-US"/>
+          </a:p>
+        </p:txBody>
+      </p:sp>
+      <p:pic>
+        <p:nvPicPr>
+          <p:cNvPr id="4" name="Picture 3">
+            <a:extLst>
+              <a:ext uri="{FF2B5EF4-FFF2-40B4-BE49-F238E27FC236}">
+                <a16:creationId xmlns:a16="http://schemas.microsoft.com/office/drawing/2014/main" id="{F03D25FF-643A-4449-A932-485EBBF2A79F}"/>
+              </a:ext>
+            </a:extLst>
+          </p:cNvPr>
+          <p:cNvPicPr>
+            <a:picLocks noChangeAspect="1"/>
+          </p:cNvPicPr>
+          <p:nvPr/>
+        </p:nvPicPr>
+        <p:blipFill rotWithShape="1">
+          <a:blip r:embed="rId2"/>
+          <a:srcRect l="23944" t="12939" r="26239" b="1824"/>
+          <a:stretch/>
+        </p:blipFill>
+        <p:spPr>
+          <a:xfrm>
+            <a:off x="2919368" y="328422"/>
+            <a:ext cx="6778305" cy="6282104"/>
+          </a:xfrm>
+          <a:prstGeom prst="rect">
+            <a:avLst/>
+          </a:prstGeom>
+        </p:spPr>
+      </p:pic>
+    </p:spTree>
+    <p:extLst>
+      <p:ext uri="{BB962C8B-B14F-4D97-AF65-F5344CB8AC3E}">
+        <p14:creationId xmlns:p14="http://schemas.microsoft.com/office/powerpoint/2010/main" val="4023115884"/>
+      </p:ext>
+    </p:extLst>
+  </p:cSld>
+  <p:clrMapOvr>
+    <a:masterClrMapping/>
+  </p:clrMapOvr>
+</p:sld>
+</file>
+
+<file path=ppt/slides/slide11.xml><?xml version="1.0" encoding="utf-8"?>
+<p:sld xmlns:a="http://schemas.openxmlformats.org/drawingml/2006/main" xmlns:r="http://schemas.openxmlformats.org/officeDocument/2006/relationships" xmlns:p="http://schemas.openxmlformats.org/presentationml/2006/main">
+  <p:cSld>
+    <p:spTree>
+      <p:nvGrpSpPr>
+        <p:cNvPr id="1" name=""/>
+        <p:cNvGrpSpPr/>
+        <p:nvPr/>
+      </p:nvGrpSpPr>
+      <p:grpSpPr>
+        <a:xfrm>
+          <a:off x="0" y="0"/>
+          <a:ext cx="0" cy="0"/>
+          <a:chOff x="0" y="0"/>
+          <a:chExt cx="0" cy="0"/>
+        </a:xfrm>
+      </p:grpSpPr>
+      <p:sp>
+        <p:nvSpPr>
+          <p:cNvPr id="2" name="Title 1">
+            <a:extLst>
+              <a:ext uri="{FF2B5EF4-FFF2-40B4-BE49-F238E27FC236}">
                 <a16:creationId xmlns:a16="http://schemas.microsoft.com/office/drawing/2014/main" id="{0E110840-F603-4F95-B58F-FF591111CE94}"/>
               </a:ext>
             </a:extLst>
@@ -3537,7 +3647,7 @@
 </p:sld>
 </file>
 
-<file path=ppt/slides/slide11.xml><?xml version="1.0" encoding="utf-8"?>
+<file path=ppt/slides/slide12.xml><?xml version="1.0" encoding="utf-8"?>
 <p:sld xmlns:a="http://schemas.openxmlformats.org/drawingml/2006/main" xmlns:r="http://schemas.openxmlformats.org/officeDocument/2006/relationships" xmlns:p="http://schemas.openxmlformats.org/presentationml/2006/main">
   <p:cSld>
     <p:spTree>
@@ -3668,6 +3778,115 @@
           <p:cNvPr id="2" name="Title 1">
             <a:extLst>
               <a:ext uri="{FF2B5EF4-FFF2-40B4-BE49-F238E27FC236}">
+                <a16:creationId xmlns:a16="http://schemas.microsoft.com/office/drawing/2014/main" id="{6DEE0325-4677-45F6-98A3-2F16B7616720}"/>
+              </a:ext>
+            </a:extLst>
+          </p:cNvPr>
+          <p:cNvSpPr>
+            <a:spLocks noGrp="1"/>
+          </p:cNvSpPr>
+          <p:nvPr>
+            <p:ph type="title"/>
+          </p:nvPr>
+        </p:nvSpPr>
+        <p:spPr/>
+        <p:txBody>
+          <a:bodyPr/>
+          <a:lstStyle/>
+          <a:p>
+            <a:endParaRPr lang="en-US"/>
+          </a:p>
+        </p:txBody>
+      </p:sp>
+      <p:sp>
+        <p:nvSpPr>
+          <p:cNvPr id="3" name="Content Placeholder 2">
+            <a:extLst>
+              <a:ext uri="{FF2B5EF4-FFF2-40B4-BE49-F238E27FC236}">
+                <a16:creationId xmlns:a16="http://schemas.microsoft.com/office/drawing/2014/main" id="{DBFA8D24-B44B-4E7C-9438-C6FF40392FB0}"/>
+              </a:ext>
+            </a:extLst>
+          </p:cNvPr>
+          <p:cNvSpPr>
+            <a:spLocks noGrp="1"/>
+          </p:cNvSpPr>
+          <p:nvPr>
+            <p:ph idx="1"/>
+          </p:nvPr>
+        </p:nvSpPr>
+        <p:spPr/>
+        <p:txBody>
+          <a:bodyPr/>
+          <a:lstStyle/>
+          <a:p>
+            <a:endParaRPr lang="en-US"/>
+          </a:p>
+        </p:txBody>
+      </p:sp>
+      <p:pic>
+        <p:nvPicPr>
+          <p:cNvPr id="4" name="Picture 3">
+            <a:extLst>
+              <a:ext uri="{FF2B5EF4-FFF2-40B4-BE49-F238E27FC236}">
+                <a16:creationId xmlns:a16="http://schemas.microsoft.com/office/drawing/2014/main" id="{0223FFFF-0E75-4205-BBFF-7A86C8F31AAB}"/>
+              </a:ext>
+            </a:extLst>
+          </p:cNvPr>
+          <p:cNvPicPr>
+            <a:picLocks noChangeAspect="1"/>
+          </p:cNvPicPr>
+          <p:nvPr/>
+        </p:nvPicPr>
+        <p:blipFill rotWithShape="1">
+          <a:blip r:embed="rId2"/>
+          <a:srcRect l="25026" t="21980" r="25394" b="12131"/>
+          <a:stretch/>
+        </p:blipFill>
+        <p:spPr>
+          <a:xfrm>
+            <a:off x="1072308" y="233625"/>
+            <a:ext cx="9197848" cy="6621200"/>
+          </a:xfrm>
+          <a:prstGeom prst="rect">
+            <a:avLst/>
+          </a:prstGeom>
+        </p:spPr>
+      </p:pic>
+    </p:spTree>
+    <p:extLst>
+      <p:ext uri="{BB962C8B-B14F-4D97-AF65-F5344CB8AC3E}">
+        <p14:creationId xmlns:p14="http://schemas.microsoft.com/office/powerpoint/2010/main" val="2561320263"/>
+      </p:ext>
+    </p:extLst>
+  </p:cSld>
+  <p:clrMapOvr>
+    <a:masterClrMapping/>
+  </p:clrMapOvr>
+</p:sld>
+</file>
+
+<file path=ppt/slides/slide3.xml><?xml version="1.0" encoding="utf-8"?>
+<p:sld xmlns:a="http://schemas.openxmlformats.org/drawingml/2006/main" xmlns:r="http://schemas.openxmlformats.org/officeDocument/2006/relationships" xmlns:p="http://schemas.openxmlformats.org/presentationml/2006/main">
+  <p:cSld>
+    <p:spTree>
+      <p:nvGrpSpPr>
+        <p:cNvPr id="1" name=""/>
+        <p:cNvGrpSpPr/>
+        <p:nvPr/>
+      </p:nvGrpSpPr>
+      <p:grpSpPr>
+        <a:xfrm>
+          <a:off x="0" y="0"/>
+          <a:ext cx="0" cy="0"/>
+          <a:chOff x="0" y="0"/>
+          <a:chExt cx="0" cy="0"/>
+        </a:xfrm>
+      </p:grpSpPr>
+      <p:sp>
+        <p:nvSpPr>
+          <p:cNvPr id="2" name="Title 1">
+            <a:extLst>
+              <a:ext uri="{FF2B5EF4-FFF2-40B4-BE49-F238E27FC236}">
                 <a16:creationId xmlns:a16="http://schemas.microsoft.com/office/drawing/2014/main" id="{C4FE007A-EC36-372B-8420-EA8B27053235}"/>
               </a:ext>
             </a:extLst>
@@ -3755,7 +3974,7 @@
 </p:sld>
 </file>
 
-<file path=ppt/slides/slide3.xml><?xml version="1.0" encoding="utf-8"?>
+<file path=ppt/slides/slide4.xml><?xml version="1.0" encoding="utf-8"?>
 <p:sld xmlns:a="http://schemas.openxmlformats.org/drawingml/2006/main" xmlns:r="http://schemas.openxmlformats.org/officeDocument/2006/relationships" xmlns:p="http://schemas.openxmlformats.org/presentationml/2006/main">
   <p:cSld>
     <p:spTree>
@@ -3864,7 +4083,7 @@
 </p:sld>
 </file>
 
-<file path=ppt/slides/slide4.xml><?xml version="1.0" encoding="utf-8"?>
+<file path=ppt/slides/slide5.xml><?xml version="1.0" encoding="utf-8"?>
 <p:sld xmlns:a="http://schemas.openxmlformats.org/drawingml/2006/main" xmlns:r="http://schemas.openxmlformats.org/officeDocument/2006/relationships" xmlns:p="http://schemas.openxmlformats.org/presentationml/2006/main">
   <p:cSld>
     <p:spTree>
@@ -4002,7 +4221,7 @@
 </p:sld>
 </file>
 
-<file path=ppt/slides/slide5.xml><?xml version="1.0" encoding="utf-8"?>
+<file path=ppt/slides/slide6.xml><?xml version="1.0" encoding="utf-8"?>
 <p:sld xmlns:a="http://schemas.openxmlformats.org/drawingml/2006/main" xmlns:r="http://schemas.openxmlformats.org/officeDocument/2006/relationships" xmlns:p="http://schemas.openxmlformats.org/presentationml/2006/main">
   <p:cSld>
     <p:spTree>
@@ -4111,7 +4330,7 @@
 </p:sld>
 </file>
 
-<file path=ppt/slides/slide6.xml><?xml version="1.0" encoding="utf-8"?>
+<file path=ppt/slides/slide7.xml><?xml version="1.0" encoding="utf-8"?>
 <p:sld xmlns:a="http://schemas.openxmlformats.org/drawingml/2006/main" xmlns:r="http://schemas.openxmlformats.org/officeDocument/2006/relationships" xmlns:p="http://schemas.openxmlformats.org/presentationml/2006/main">
   <p:cSld>
     <p:spTree>
@@ -4249,7 +4468,7 @@
 </p:sld>
 </file>
 
-<file path=ppt/slides/slide7.xml><?xml version="1.0" encoding="utf-8"?>
+<file path=ppt/slides/slide8.xml><?xml version="1.0" encoding="utf-8"?>
 <p:sld xmlns:a="http://schemas.openxmlformats.org/drawingml/2006/main" xmlns:r="http://schemas.openxmlformats.org/officeDocument/2006/relationships" xmlns:p="http://schemas.openxmlformats.org/presentationml/2006/main">
   <p:cSld>
     <p:spTree>
@@ -4358,103 +4577,6 @@
 </p:sld>
 </file>
 
-<file path=ppt/slides/slide8.xml><?xml version="1.0" encoding="utf-8"?>
-<p:sld xmlns:a="http://schemas.openxmlformats.org/drawingml/2006/main" xmlns:r="http://schemas.openxmlformats.org/officeDocument/2006/relationships" xmlns:p="http://schemas.openxmlformats.org/presentationml/2006/main">
-  <p:cSld>
-    <p:spTree>
-      <p:nvGrpSpPr>
-        <p:cNvPr id="1" name=""/>
-        <p:cNvGrpSpPr/>
-        <p:nvPr/>
-      </p:nvGrpSpPr>
-      <p:grpSpPr>
-        <a:xfrm>
-          <a:off x="0" y="0"/>
-          <a:ext cx="0" cy="0"/>
-          <a:chOff x="0" y="0"/>
-          <a:chExt cx="0" cy="0"/>
-        </a:xfrm>
-      </p:grpSpPr>
-      <p:sp>
-        <p:nvSpPr>
-          <p:cNvPr id="2" name="Title 1">
-            <a:extLst>
-              <a:ext uri="{FF2B5EF4-FFF2-40B4-BE49-F238E27FC236}">
-                <a16:creationId xmlns:a16="http://schemas.microsoft.com/office/drawing/2014/main" id="{6F25426D-49CE-4866-992B-BD5EE93A10DA}"/>
-              </a:ext>
-            </a:extLst>
-          </p:cNvPr>
-          <p:cNvSpPr>
-            <a:spLocks noGrp="1"/>
-          </p:cNvSpPr>
-          <p:nvPr>
-            <p:ph type="title"/>
-          </p:nvPr>
-        </p:nvSpPr>
-        <p:spPr/>
-        <p:txBody>
-          <a:bodyPr/>
-          <a:lstStyle/>
-          <a:p>
-            <a:endParaRPr lang="en-US"/>
-          </a:p>
-        </p:txBody>
-      </p:sp>
-      <p:pic>
-        <p:nvPicPr>
-          <p:cNvPr id="5" name="Content Placeholder 4">
-            <a:extLst>
-              <a:ext uri="{FF2B5EF4-FFF2-40B4-BE49-F238E27FC236}">
-                <a16:creationId xmlns:a16="http://schemas.microsoft.com/office/drawing/2014/main" id="{64F6F3F8-0D62-4BBB-AD3A-D6A324357DD9}"/>
-              </a:ext>
-            </a:extLst>
-          </p:cNvPr>
-          <p:cNvPicPr>
-            <a:picLocks noGrp="1" noChangeAspect="1"/>
-          </p:cNvPicPr>
-          <p:nvPr>
-            <p:ph idx="1"/>
-          </p:nvPr>
-        </p:nvPicPr>
-        <p:blipFill>
-          <a:blip r:embed="rId2">
-            <a:duotone>
-              <a:prstClr val="black"/>
-              <a:schemeClr val="accent3">
-                <a:tint val="45000"/>
-                <a:satMod val="400000"/>
-              </a:schemeClr>
-            </a:duotone>
-            <a:extLst>
-              <a:ext uri="{28A0092B-C50C-407E-A947-70E740481C1C}">
-                <a14:useLocalDpi xmlns:a14="http://schemas.microsoft.com/office/drawing/2010/main" val="0"/>
-              </a:ext>
-            </a:extLst>
-          </a:blip>
-          <a:stretch>
-            <a:fillRect/>
-          </a:stretch>
-        </p:blipFill>
-        <p:spPr>
-          <a:xfrm>
-            <a:off x="2564489" y="469783"/>
-            <a:ext cx="5436511" cy="5436511"/>
-          </a:xfrm>
-        </p:spPr>
-      </p:pic>
-    </p:spTree>
-    <p:extLst>
-      <p:ext uri="{BB962C8B-B14F-4D97-AF65-F5344CB8AC3E}">
-        <p14:creationId xmlns:p14="http://schemas.microsoft.com/office/powerpoint/2010/main" val="3005326315"/>
-      </p:ext>
-    </p:extLst>
-  </p:cSld>
-  <p:clrMapOvr>
-    <a:masterClrMapping/>
-  </p:clrMapOvr>
-</p:sld>
-</file>
-
 <file path=ppt/slides/slide9.xml><?xml version="1.0" encoding="utf-8"?>
 <p:sld xmlns:a="http://schemas.openxmlformats.org/drawingml/2006/main" xmlns:r="http://schemas.openxmlformats.org/officeDocument/2006/relationships" xmlns:p="http://schemas.openxmlformats.org/presentationml/2006/main">
   <p:cSld>
@@ -4477,7 +4599,7 @@
           <p:cNvPr id="2" name="Title 1">
             <a:extLst>
               <a:ext uri="{FF2B5EF4-FFF2-40B4-BE49-F238E27FC236}">
-                <a16:creationId xmlns:a16="http://schemas.microsoft.com/office/drawing/2014/main" id="{0BCB046E-2FC3-4408-8943-A295B7B1A566}"/>
+                <a16:creationId xmlns:a16="http://schemas.microsoft.com/office/drawing/2014/main" id="{6F25426D-49CE-4866-992B-BD5EE93A10DA}"/>
               </a:ext>
             </a:extLst>
           </p:cNvPr>
@@ -4486,31 +4608,6 @@
           </p:cNvSpPr>
           <p:nvPr>
             <p:ph type="title"/>
-          </p:nvPr>
-        </p:nvSpPr>
-        <p:spPr/>
-        <p:txBody>
-          <a:bodyPr/>
-          <a:lstStyle/>
-          <a:p>
-            <a:endParaRPr lang="en-US"/>
-          </a:p>
-        </p:txBody>
-      </p:sp>
-      <p:sp>
-        <p:nvSpPr>
-          <p:cNvPr id="3" name="Content Placeholder 2">
-            <a:extLst>
-              <a:ext uri="{FF2B5EF4-FFF2-40B4-BE49-F238E27FC236}">
-                <a16:creationId xmlns:a16="http://schemas.microsoft.com/office/drawing/2014/main" id="{52413933-3B51-4EDA-84AA-EFE19A6C69A1}"/>
-              </a:ext>
-            </a:extLst>
-          </p:cNvPr>
-          <p:cNvSpPr>
-            <a:spLocks noGrp="1"/>
-          </p:cNvSpPr>
-          <p:nvPr>
-            <p:ph idx="1"/>
           </p:nvPr>
         </p:nvSpPr>
         <p:spPr/>
@@ -4524,37 +4621,50 @@
       </p:sp>
       <p:pic>
         <p:nvPicPr>
-          <p:cNvPr id="4" name="Picture 3">
-            <a:extLst>
-              <a:ext uri="{FF2B5EF4-FFF2-40B4-BE49-F238E27FC236}">
-                <a16:creationId xmlns:a16="http://schemas.microsoft.com/office/drawing/2014/main" id="{F03D25FF-643A-4449-A932-485EBBF2A79F}"/>
+          <p:cNvPr id="5" name="Content Placeholder 4">
+            <a:extLst>
+              <a:ext uri="{FF2B5EF4-FFF2-40B4-BE49-F238E27FC236}">
+                <a16:creationId xmlns:a16="http://schemas.microsoft.com/office/drawing/2014/main" id="{64F6F3F8-0D62-4BBB-AD3A-D6A324357DD9}"/>
               </a:ext>
             </a:extLst>
           </p:cNvPr>
           <p:cNvPicPr>
-            <a:picLocks noChangeAspect="1"/>
+            <a:picLocks noGrp="1" noChangeAspect="1"/>
           </p:cNvPicPr>
-          <p:nvPr/>
+          <p:nvPr>
+            <p:ph idx="1"/>
+          </p:nvPr>
         </p:nvPicPr>
-        <p:blipFill rotWithShape="1">
-          <a:blip r:embed="rId2"/>
-          <a:srcRect l="23944" t="12939" r="26239" b="1824"/>
-          <a:stretch/>
+        <p:blipFill>
+          <a:blip r:embed="rId2">
+            <a:duotone>
+              <a:prstClr val="black"/>
+              <a:schemeClr val="accent3">
+                <a:tint val="45000"/>
+                <a:satMod val="400000"/>
+              </a:schemeClr>
+            </a:duotone>
+            <a:extLst>
+              <a:ext uri="{28A0092B-C50C-407E-A947-70E740481C1C}">
+                <a14:useLocalDpi xmlns:a14="http://schemas.microsoft.com/office/drawing/2010/main" val="0"/>
+              </a:ext>
+            </a:extLst>
+          </a:blip>
+          <a:stretch>
+            <a:fillRect/>
+          </a:stretch>
         </p:blipFill>
         <p:spPr>
           <a:xfrm>
-            <a:off x="2919368" y="328422"/>
-            <a:ext cx="6778305" cy="6282104"/>
+            <a:off x="2564489" y="469783"/>
+            <a:ext cx="5436511" cy="5436511"/>
           </a:xfrm>
-          <a:prstGeom prst="rect">
-            <a:avLst/>
-          </a:prstGeom>
         </p:spPr>
       </p:pic>
     </p:spTree>
     <p:extLst>
       <p:ext uri="{BB962C8B-B14F-4D97-AF65-F5344CB8AC3E}">
-        <p14:creationId xmlns:p14="http://schemas.microsoft.com/office/powerpoint/2010/main" val="4023115884"/>
+        <p14:creationId xmlns:p14="http://schemas.microsoft.com/office/powerpoint/2010/main" val="3005326315"/>
       </p:ext>
     </p:extLst>
   </p:cSld>

</xml_diff>